<commit_message>
Update presentation files for improved content and clarity
</commit_message>
<xml_diff>
--- a/description/prezentacja_EN.pptx
+++ b/description/prezentacja_EN.pptx
@@ -10737,7 +10737,7 @@
                   <a:srgbClr val="E2E8F0"/>
                 </a:solidFill>
               </a:rPr>
-              <a:t>psycopg2-binary 2.9.9</a:t>
+              <a:t>SQLAlchemy 2.0.36 (ORM)</a:t>
             </a:r>
           </a:p>
         </p:txBody>
@@ -10814,7 +10814,7 @@
                   <a:srgbClr val="E2E8F0"/>
                 </a:solidFill>
               </a:rPr>
-              <a:t>requests 2.32.3</a:t>
+              <a:t>psycopg2-binary 2.9.9</a:t>
             </a:r>
           </a:p>
         </p:txBody>
@@ -10891,7 +10891,7 @@
                   <a:srgbClr val="E2E8F0"/>
                 </a:solidFill>
               </a:rPr>
-              <a:t>python-dotenv 1.0.1</a:t>
+              <a:t>requests 2.32.3</a:t>
             </a:r>
           </a:p>
         </p:txBody>
@@ -11466,7 +11466,7 @@
                   <a:srgbClr val="E2E8F0"/>
                 </a:solidFill>
               </a:rPr>
-              <a:t>Database schema – earthquakes table</a:t>
+              <a:t>Database schema – Earthquake ORM model</a:t>
             </a:r>
           </a:p>
         </p:txBody>
@@ -11500,7 +11500,7 @@
                   <a:srgbClr val="94A3B8"/>
                 </a:solidFill>
               </a:rPr>
-              <a:t>Schemat bazy danych – tabela earthquakes</a:t>
+              <a:t>Schemat bazy danych – model ORM Earthquake</a:t>
             </a:r>
           </a:p>
         </p:txBody>

</xml_diff>